<commit_message>
Add YouTube video pitch link to VOID-NAV deck
Co-Authored-By: Claude Opus 5.5 <noreply@anthropic.com>
Claude-Session: https://claude.ai/code/session_01D6xviB9sgxBFmNSDuv4vfX
</commit_message>
<xml_diff>
--- a/deck/VOID-NAV_QiskitFallFest.pptx
+++ b/deck/VOID-NAV_QiskitFallFest.pptx
@@ -5791,6 +5791,131 @@
           </a:prstGeom>
         </p:spPr>
       </p:pic>
+      <p:sp>
+        <p:nvSpPr>
+          <p:cNvPr id="2097170" name="Rounded Rectangle 2097169"/>
+          <p:cNvSpPr/>
+          <p:nvPr/>
+        </p:nvSpPr>
+        <p:spPr>
+          <a:xfrm>
+            <a:off x="6675120" y="4617720"/>
+            <a:ext cx="4937760" cy="566928"/>
+          </a:xfrm>
+          <a:prstGeom prst="roundRect">
+            <a:avLst>
+              <a:gd name="adj" fmla="val 20000"/>
+            </a:avLst>
+          </a:prstGeom>
+          <a:solidFill>
+            <a:srgbClr val="FDEBF5"/>
+          </a:solidFill>
+          <a:ln>
+            <a:noFill/>
+          </a:ln>
+          <a:effectLst/>
+        </p:spPr>
+        <p:style>
+          <a:lnRef idx="1">
+            <a:schemeClr val="accent1"/>
+          </a:lnRef>
+          <a:fillRef idx="3">
+            <a:schemeClr val="accent1"/>
+          </a:fillRef>
+          <a:effectRef idx="2">
+            <a:schemeClr val="accent1"/>
+          </a:effectRef>
+          <a:fontRef idx="minor">
+            <a:schemeClr val="lt1"/>
+          </a:fontRef>
+        </p:style>
+        <p:txBody>
+          <a:bodyPr rtlCol="0" anchor="ctr"/>
+          <a:lstStyle/>
+          <a:p>
+            <a:pPr algn="ctr"/>
+          </a:p>
+        </p:txBody>
+      </p:sp>
+      <p:sp>
+        <p:nvSpPr>
+          <p:cNvPr id="2097171" name="TextBox 2097170"/>
+          <p:cNvSpPr txBox="1"/>
+          <p:nvPr/>
+        </p:nvSpPr>
+        <p:spPr>
+          <a:xfrm>
+            <a:off x="6858000" y="4617720"/>
+            <a:ext cx="1737360" cy="566928"/>
+          </a:xfrm>
+          <a:prstGeom prst="rect">
+            <a:avLst/>
+          </a:prstGeom>
+          <a:noFill/>
+        </p:spPr>
+        <p:txBody>
+          <a:bodyPr wrap="square" lIns="0" rIns="0" tIns="0" bIns="0" anchor="ctr">
+            <a:spAutoFit/>
+          </a:bodyPr>
+          <a:lstStyle/>
+          <a:p>
+            <a:pPr algn="l">
+              <a:spcAft>
+                <a:spcPts val="0"/>
+              </a:spcAft>
+            </a:pPr>
+            <a:r>
+              <a:rPr sz="1000" b="1" i="0" spc="100">
+                <a:solidFill>
+                  <a:srgbClr val="F237A6"/>
+                </a:solidFill>
+                <a:latin typeface="Consolas"/>
+              </a:rPr>
+              <a:t>VIDEO PITCH</a:t>
+            </a:r>
+          </a:p>
+        </p:txBody>
+      </p:sp>
+      <p:sp>
+        <p:nvSpPr>
+          <p:cNvPr id="2097172" name="TextBox 2097171"/>
+          <p:cNvSpPr txBox="1"/>
+          <p:nvPr/>
+        </p:nvSpPr>
+        <p:spPr>
+          <a:xfrm>
+            <a:off x="8549640" y="4617720"/>
+            <a:ext cx="3017520" cy="566928"/>
+          </a:xfrm>
+          <a:prstGeom prst="rect">
+            <a:avLst/>
+          </a:prstGeom>
+          <a:noFill/>
+        </p:spPr>
+        <p:txBody>
+          <a:bodyPr wrap="square" lIns="0" rIns="0" tIns="0" bIns="0" anchor="ctr">
+            <a:spAutoFit/>
+          </a:bodyPr>
+          <a:lstStyle/>
+          <a:p>
+            <a:pPr algn="l">
+              <a:spcAft>
+                <a:spcPts val="0"/>
+              </a:spcAft>
+            </a:pPr>
+            <a:r>
+              <a:rPr sz="1400" b="1" i="0">
+                <a:solidFill>
+                  <a:srgbClr val="8A145E"/>
+                </a:solidFill>
+                <a:latin typeface="Calibri"/>
+                <a:hlinkClick r:id="rId5"/>
+              </a:rPr>
+              <a:t>https://youtu.be/BV2KYV-yhL0</a:t>
+            </a:r>
+          </a:p>
+        </p:txBody>
+      </p:sp>
     </p:spTree>
   </p:cSld>
   <p:clrMapOvr>
@@ -7255,7 +7380,102 @@
       </p:sp>
       <p:sp>
         <p:nvSpPr>
-          <p:cNvPr id="2097194" name="TextBox 2097193"/>
+          <p:cNvPr id="2097194" name="Rounded Rectangle 2097193"/>
+          <p:cNvSpPr/>
+          <p:nvPr/>
+        </p:nvSpPr>
+        <p:spPr>
+          <a:xfrm>
+            <a:off x="8641080" y="5047488"/>
+            <a:ext cx="2788920" cy="365760"/>
+          </a:xfrm>
+          <a:prstGeom prst="roundRect">
+            <a:avLst>
+              <a:gd name="adj" fmla="val 30000"/>
+            </a:avLst>
+          </a:prstGeom>
+          <a:solidFill>
+            <a:srgbClr val="FFFFFF"/>
+          </a:solidFill>
+          <a:ln>
+            <a:noFill/>
+          </a:ln>
+          <a:effectLst/>
+        </p:spPr>
+        <p:style>
+          <a:lnRef idx="1">
+            <a:schemeClr val="accent1"/>
+          </a:lnRef>
+          <a:fillRef idx="3">
+            <a:schemeClr val="accent1"/>
+          </a:fillRef>
+          <a:effectRef idx="2">
+            <a:schemeClr val="accent1"/>
+          </a:effectRef>
+          <a:fontRef idx="minor">
+            <a:schemeClr val="lt1"/>
+          </a:fontRef>
+        </p:style>
+        <p:txBody>
+          <a:bodyPr rtlCol="0" anchor="ctr"/>
+          <a:lstStyle/>
+          <a:p>
+            <a:pPr algn="ctr"/>
+          </a:p>
+        </p:txBody>
+      </p:sp>
+      <p:sp>
+        <p:nvSpPr>
+          <p:cNvPr id="2097195" name="TextBox 2097194"/>
+          <p:cNvSpPr txBox="1"/>
+          <p:nvPr/>
+        </p:nvSpPr>
+        <p:spPr>
+          <a:xfrm>
+            <a:off x="8641080" y="5047488"/>
+            <a:ext cx="2788920" cy="365760"/>
+          </a:xfrm>
+          <a:prstGeom prst="rect">
+            <a:avLst/>
+          </a:prstGeom>
+          <a:noFill/>
+        </p:spPr>
+        <p:txBody>
+          <a:bodyPr wrap="square" lIns="0" rIns="0" tIns="0" bIns="0" anchor="ctr">
+            <a:spAutoFit/>
+          </a:bodyPr>
+          <a:lstStyle/>
+          <a:p>
+            <a:pPr algn="ctr">
+              <a:spcAft>
+                <a:spcPts val="0"/>
+              </a:spcAft>
+            </a:pPr>
+            <a:r>
+              <a:rPr sz="1100" b="1" i="0">
+                <a:solidFill>
+                  <a:srgbClr val="F237A6"/>
+                </a:solidFill>
+                <a:latin typeface="Calibri"/>
+              </a:rPr>
+              <a:t>Video: </a:t>
+            </a:r>
+            <a:r>
+              <a:rPr sz="1100" b="1" i="0">
+                <a:solidFill>
+                  <a:srgbClr val="8A145E"/>
+                </a:solidFill>
+                <a:latin typeface="Calibri"/>
+                <a:hlinkClick r:id="rId4"/>
+              </a:rPr>
+              <a:t>https://youtu.be/BV2KYV-yhL0</a:t>
+            </a:r>
+          </a:p>
+        </p:txBody>
+      </p:sp>
+      <p:sp>
+        <p:nvSpPr>
+          <p:cNvPr id="2097196" name="TextBox 2097195"/>
           <p:cNvSpPr txBox="1"/>
           <p:nvPr/>
         </p:nvSpPr>

</xml_diff>